<commit_message>
Update AI for Content Creation — The Basics.pptx
</commit_message>
<xml_diff>
--- a/Prestentations/AI for Content Creation — The Basics.pptx
+++ b/Prestentations/AI for Content Creation — The Basics.pptx
@@ -59,7 +59,7 @@
       <p:boldItalic r:id="rId45"/>
     </p:embeddedFont>
     <p:embeddedFont>
-      <p:font typeface="Fraunces"/>
+      <p:font typeface="Fraunces" pitchFamily="2" charset="77"/>
       <p:regular r:id="rId46"/>
       <p:bold r:id="rId47"/>
       <p:italic r:id="rId48"/>
@@ -5012,10 +5012,10 @@
               <a:buNone/>
             </a:pPr>
             <a:r>
-              <a:rPr lang="en-US"/>
+              <a:rPr lang="en-US" dirty="0"/>
               <a:t>Demo framing, about 30 seconds. Tell people they do not need to type along; the hands-on repeats exactly these four steps with the Loop Tote. Ask them to watch two things: how the prompt is built, and what you check before accepting the output.</a:t>
             </a:r>
-            <a:endParaRPr/>
+            <a:endParaRPr dirty="0"/>
           </a:p>
         </p:txBody>
       </p:sp>
@@ -11545,7 +11545,7 @@
 </file>
 
 <file path=ppt/slides/slide14.xml><?xml version="1.0" encoding="utf-8"?>
-<p:sld xmlns:a="http://schemas.openxmlformats.org/drawingml/2006/main" xmlns:r="http://schemas.openxmlformats.org/officeDocument/2006/relationships" xmlns:p="http://schemas.openxmlformats.org/presentationml/2006/main">
+<p:sld xmlns:a="http://schemas.openxmlformats.org/drawingml/2006/main" xmlns:r="http://schemas.openxmlformats.org/officeDocument/2006/relationships" xmlns:p="http://schemas.openxmlformats.org/presentationml/2006/main" show="0">
   <p:cSld>
     <p:bg>
       <p:bgPr>
@@ -11923,7 +11923,7 @@
 </file>
 
 <file path=ppt/slides/slide15.xml><?xml version="1.0" encoding="utf-8"?>
-<p:sld xmlns:a="http://schemas.openxmlformats.org/drawingml/2006/main" xmlns:r="http://schemas.openxmlformats.org/officeDocument/2006/relationships" xmlns:p="http://schemas.openxmlformats.org/presentationml/2006/main">
+<p:sld xmlns:a="http://schemas.openxmlformats.org/drawingml/2006/main" xmlns:r="http://schemas.openxmlformats.org/officeDocument/2006/relationships" xmlns:p="http://schemas.openxmlformats.org/presentationml/2006/main" show="0">
   <p:cSld>
     <p:bg>
       <p:bgPr>
@@ -12474,7 +12474,7 @@
 </file>
 
 <file path=ppt/slides/slide16.xml><?xml version="1.0" encoding="utf-8"?>
-<p:sld xmlns:a="http://schemas.openxmlformats.org/drawingml/2006/main" xmlns:r="http://schemas.openxmlformats.org/officeDocument/2006/relationships" xmlns:p="http://schemas.openxmlformats.org/presentationml/2006/main">
+<p:sld xmlns:a="http://schemas.openxmlformats.org/drawingml/2006/main" xmlns:r="http://schemas.openxmlformats.org/officeDocument/2006/relationships" xmlns:p="http://schemas.openxmlformats.org/presentationml/2006/main" show="0">
   <p:cSld>
     <p:bg>
       <p:bgPr>
@@ -13983,7 +13983,7 @@
 </file>
 
 <file path=ppt/slides/slide17.xml><?xml version="1.0" encoding="utf-8"?>
-<p:sld xmlns:a="http://schemas.openxmlformats.org/drawingml/2006/main" xmlns:r="http://schemas.openxmlformats.org/officeDocument/2006/relationships" xmlns:p="http://schemas.openxmlformats.org/presentationml/2006/main">
+<p:sld xmlns:a="http://schemas.openxmlformats.org/drawingml/2006/main" xmlns:r="http://schemas.openxmlformats.org/officeDocument/2006/relationships" xmlns:p="http://schemas.openxmlformats.org/presentationml/2006/main" show="0">
   <p:cSld>
     <p:bg>
       <p:bgPr>
@@ -15134,7 +15134,7 @@
 </file>
 
 <file path=ppt/slides/slide18.xml><?xml version="1.0" encoding="utf-8"?>
-<p:sld xmlns:a="http://schemas.openxmlformats.org/drawingml/2006/main" xmlns:r="http://schemas.openxmlformats.org/officeDocument/2006/relationships" xmlns:p="http://schemas.openxmlformats.org/presentationml/2006/main">
+<p:sld xmlns:a="http://schemas.openxmlformats.org/drawingml/2006/main" xmlns:r="http://schemas.openxmlformats.org/officeDocument/2006/relationships" xmlns:p="http://schemas.openxmlformats.org/presentationml/2006/main" show="0">
   <p:cSld>
     <p:bg>
       <p:bgPr>
@@ -16301,7 +16301,7 @@
 </file>
 
 <file path=ppt/slides/slide19.xml><?xml version="1.0" encoding="utf-8"?>
-<p:sld xmlns:a="http://schemas.openxmlformats.org/drawingml/2006/main" xmlns:r="http://schemas.openxmlformats.org/officeDocument/2006/relationships" xmlns:p="http://schemas.openxmlformats.org/presentationml/2006/main">
+<p:sld xmlns:a="http://schemas.openxmlformats.org/drawingml/2006/main" xmlns:r="http://schemas.openxmlformats.org/officeDocument/2006/relationships" xmlns:p="http://schemas.openxmlformats.org/presentationml/2006/main" show="0">
   <p:cSld>
     <p:bg>
       <p:bgPr>
@@ -17602,7 +17602,7 @@
 </file>
 
 <file path=ppt/slides/slide20.xml><?xml version="1.0" encoding="utf-8"?>
-<p:sld xmlns:a="http://schemas.openxmlformats.org/drawingml/2006/main" xmlns:r="http://schemas.openxmlformats.org/officeDocument/2006/relationships" xmlns:p="http://schemas.openxmlformats.org/presentationml/2006/main">
+<p:sld xmlns:a="http://schemas.openxmlformats.org/drawingml/2006/main" xmlns:r="http://schemas.openxmlformats.org/officeDocument/2006/relationships" xmlns:p="http://schemas.openxmlformats.org/presentationml/2006/main" show="0">
   <p:cSld>
     <p:bg>
       <p:bgPr>
@@ -18725,7 +18725,7 @@
 </file>
 
 <file path=ppt/slides/slide21.xml><?xml version="1.0" encoding="utf-8"?>
-<p:sld xmlns:a="http://schemas.openxmlformats.org/drawingml/2006/main" xmlns:r="http://schemas.openxmlformats.org/officeDocument/2006/relationships" xmlns:p="http://schemas.openxmlformats.org/presentationml/2006/main">
+<p:sld xmlns:a="http://schemas.openxmlformats.org/drawingml/2006/main" xmlns:r="http://schemas.openxmlformats.org/officeDocument/2006/relationships" xmlns:p="http://schemas.openxmlformats.org/presentationml/2006/main" show="0">
   <p:cSld>
     <p:bg>
       <p:bgPr>
@@ -19224,7 +19224,7 @@
 </file>
 
 <file path=ppt/slides/slide22.xml><?xml version="1.0" encoding="utf-8"?>
-<p:sld xmlns:a="http://schemas.openxmlformats.org/drawingml/2006/main" xmlns:r="http://schemas.openxmlformats.org/officeDocument/2006/relationships" xmlns:p="http://schemas.openxmlformats.org/presentationml/2006/main">
+<p:sld xmlns:a="http://schemas.openxmlformats.org/drawingml/2006/main" xmlns:r="http://schemas.openxmlformats.org/officeDocument/2006/relationships" xmlns:p="http://schemas.openxmlformats.org/presentationml/2006/main" show="0">
   <p:cSld>
     <p:bg>
       <p:bgPr>
@@ -20915,7 +20915,7 @@
 </file>
 
 <file path=ppt/slides/slide23.xml><?xml version="1.0" encoding="utf-8"?>
-<p:sld xmlns:a="http://schemas.openxmlformats.org/drawingml/2006/main" xmlns:r="http://schemas.openxmlformats.org/officeDocument/2006/relationships" xmlns:p="http://schemas.openxmlformats.org/presentationml/2006/main">
+<p:sld xmlns:a="http://schemas.openxmlformats.org/drawingml/2006/main" xmlns:r="http://schemas.openxmlformats.org/officeDocument/2006/relationships" xmlns:p="http://schemas.openxmlformats.org/presentationml/2006/main" show="0">
   <p:cSld>
     <p:bg>
       <p:bgPr>
@@ -22066,7 +22066,7 @@
 </file>
 
 <file path=ppt/slides/slide24.xml><?xml version="1.0" encoding="utf-8"?>
-<p:sld xmlns:a="http://schemas.openxmlformats.org/drawingml/2006/main" xmlns:r="http://schemas.openxmlformats.org/officeDocument/2006/relationships" xmlns:p="http://schemas.openxmlformats.org/presentationml/2006/main">
+<p:sld xmlns:a="http://schemas.openxmlformats.org/drawingml/2006/main" xmlns:r="http://schemas.openxmlformats.org/officeDocument/2006/relationships" xmlns:p="http://schemas.openxmlformats.org/presentationml/2006/main" show="0">
   <p:cSld>
     <p:bg>
       <p:bgPr>
@@ -23161,7 +23161,7 @@
 </file>
 
 <file path=ppt/slides/slide25.xml><?xml version="1.0" encoding="utf-8"?>
-<p:sld xmlns:a="http://schemas.openxmlformats.org/drawingml/2006/main" xmlns:r="http://schemas.openxmlformats.org/officeDocument/2006/relationships" xmlns:p="http://schemas.openxmlformats.org/presentationml/2006/main">
+<p:sld xmlns:a="http://schemas.openxmlformats.org/drawingml/2006/main" xmlns:r="http://schemas.openxmlformats.org/officeDocument/2006/relationships" xmlns:p="http://schemas.openxmlformats.org/presentationml/2006/main" show="0">
   <p:cSld>
     <p:bg>
       <p:bgPr>
@@ -24216,7 +24216,7 @@
 </file>
 
 <file path=ppt/slides/slide26.xml><?xml version="1.0" encoding="utf-8"?>
-<p:sld xmlns:a="http://schemas.openxmlformats.org/drawingml/2006/main" xmlns:r="http://schemas.openxmlformats.org/officeDocument/2006/relationships" xmlns:p="http://schemas.openxmlformats.org/presentationml/2006/main">
+<p:sld xmlns:a="http://schemas.openxmlformats.org/drawingml/2006/main" xmlns:r="http://schemas.openxmlformats.org/officeDocument/2006/relationships" xmlns:p="http://schemas.openxmlformats.org/presentationml/2006/main" show="0">
   <p:cSld>
     <p:bg>
       <p:bgPr>
@@ -25339,7 +25339,7 @@
 </file>
 
 <file path=ppt/slides/slide27.xml><?xml version="1.0" encoding="utf-8"?>
-<p:sld xmlns:a="http://schemas.openxmlformats.org/drawingml/2006/main" xmlns:r="http://schemas.openxmlformats.org/officeDocument/2006/relationships" xmlns:p="http://schemas.openxmlformats.org/presentationml/2006/main">
+<p:sld xmlns:a="http://schemas.openxmlformats.org/drawingml/2006/main" xmlns:r="http://schemas.openxmlformats.org/officeDocument/2006/relationships" xmlns:p="http://schemas.openxmlformats.org/presentationml/2006/main" show="0">
   <p:cSld>
     <p:bg>
       <p:bgPr>
@@ -28395,7 +28395,7 @@
         <p:spPr>
           <a:xfrm>
             <a:off x="813816" y="2148840"/>
-            <a:ext cx="5184648" cy="4185761"/>
+            <a:ext cx="5184648" cy="3754874"/>
           </a:xfrm>
           <a:prstGeom prst="rect">
             <a:avLst/>
@@ -28643,36 +28643,6 @@
                 <a:srgbClr val="1E3A2F"/>
               </a:solidFill>
             </a:endParaRPr>
-          </a:p>
-          <a:p>
-            <a:pPr algn="l"/>
-            <a:r>
-              <a:rPr b="1" dirty="0" err="1">
-                <a:solidFill>
-                  <a:srgbClr val="1E3A2F"/>
-                </a:solidFill>
-              </a:rPr>
-              <a:t>loopcycle_tote_orders.csv</a:t>
-            </a:r>
-            <a:r>
-              <a:rPr b="1" dirty="0">
-                <a:solidFill>
-                  <a:srgbClr val="1E3A2F"/>
-                </a:solidFill>
-              </a:rPr>
-              <a:t>  (optional)</a:t>
-            </a:r>
-          </a:p>
-          <a:p>
-            <a:pPr algn="l"/>
-            <a:r>
-              <a:rPr b="0" dirty="0">
-                <a:solidFill>
-                  <a:srgbClr val="1E3A2F"/>
-                </a:solidFill>
-              </a:rPr>
-              <a:t>Link reviews to orders for delivery-time follow-ups.</a:t>
-            </a:r>
           </a:p>
         </p:txBody>
       </p:sp>
@@ -30650,7 +30620,7 @@
         <p:spPr>
           <a:xfrm>
             <a:off x="923544" y="2258568"/>
-            <a:ext cx="6016752" cy="3182859"/>
+            <a:ext cx="6016752" cy="2559611"/>
           </a:xfrm>
           <a:prstGeom prst="rect">
             <a:avLst/>
@@ -30907,89 +30877,6 @@
                 <a:srgbClr val="FBF3E8"/>
               </a:solidFill>
             </a:endParaRPr>
-          </a:p>
-          <a:p>
-            <a:pPr algn="l">
-              <a:lnSpc>
-                <a:spcPct val="150000"/>
-              </a:lnSpc>
-            </a:pPr>
-            <a:r>
-              <a:rPr sz="900" dirty="0">
-                <a:solidFill>
-                  <a:srgbClr val="FBF3E8"/>
-                </a:solidFill>
-              </a:rPr>
-              <a:t>Follow-up: </a:t>
-            </a:r>
-            <a:endParaRPr lang="en-US" sz="900" dirty="0">
-              <a:solidFill>
-                <a:srgbClr val="FBF3E8"/>
-              </a:solidFill>
-            </a:endParaRPr>
-          </a:p>
-          <a:p>
-            <a:pPr algn="l">
-              <a:lnSpc>
-                <a:spcPct val="150000"/>
-              </a:lnSpc>
-            </a:pPr>
-            <a:r>
-              <a:rPr sz="900" dirty="0">
-                <a:solidFill>
-                  <a:srgbClr val="FBF3E8"/>
-                </a:solidFill>
-              </a:rPr>
-              <a:t>if I also give you </a:t>
-            </a:r>
-            <a:r>
-              <a:rPr sz="900" dirty="0" err="1">
-                <a:solidFill>
-                  <a:srgbClr val="FBF3E8"/>
-                </a:solidFill>
-              </a:rPr>
-              <a:t>loopcycle_tote_orders.csv</a:t>
-            </a:r>
-            <a:r>
-              <a:rPr sz="900" dirty="0">
-                <a:solidFill>
-                  <a:srgbClr val="FBF3E8"/>
-                </a:solidFill>
-              </a:rPr>
-              <a:t>, how</a:t>
-            </a:r>
-            <a:r>
-              <a:rPr lang="en-US" sz="900" dirty="0">
-                <a:solidFill>
-                  <a:srgbClr val="FBF3E8"/>
-                </a:solidFill>
-              </a:rPr>
-              <a:t> </a:t>
-            </a:r>
-            <a:r>
-              <a:rPr sz="900" dirty="0">
-                <a:solidFill>
-                  <a:srgbClr val="FBF3E8"/>
-                </a:solidFill>
-              </a:rPr>
-              <a:t>would you check whether delivery complaints match longer delivery</a:t>
-            </a:r>
-            <a:r>
-              <a:rPr lang="en-US" sz="900" dirty="0">
-                <a:solidFill>
-                  <a:srgbClr val="FBF3E8"/>
-                </a:solidFill>
-              </a:rPr>
-              <a:t> </a:t>
-            </a:r>
-            <a:r>
-              <a:rPr sz="900" dirty="0">
-                <a:solidFill>
-                  <a:srgbClr val="FBF3E8"/>
-                </a:solidFill>
-              </a:rPr>
-              <a:t>times? Describe the join and columns, then do it.</a:t>
-            </a:r>
           </a:p>
         </p:txBody>
       </p:sp>
@@ -33164,7 +33051,7 @@
         </p:nvSpPr>
         <p:spPr>
           <a:xfrm>
-            <a:off x="715523" y="2870279"/>
+            <a:off x="812800" y="2844807"/>
             <a:ext cx="10883392" cy="1625600"/>
           </a:xfrm>
           <a:prstGeom prst="rect">
@@ -33216,7 +33103,25 @@
                 <a:cs typeface="Fraunces"/>
                 <a:sym typeface="Fraunces"/>
               </a:rPr>
-              <a:t>Chatbot Agent</a:t>
+              <a:t>Chatbot Agent using </a:t>
+            </a:r>
+            <a:r>
+              <a:rPr kumimoji="0" lang="en-US" sz="6000" b="0" i="0" u="none" strike="noStrike" kern="0" cap="none" spc="0" normalizeH="0" baseline="0" noProof="0" dirty="0" err="1">
+                <a:ln>
+                  <a:noFill/>
+                </a:ln>
+                <a:solidFill>
+                  <a:srgbClr val="1E3A2F"/>
+                </a:solidFill>
+                <a:effectLst/>
+                <a:uLnTx/>
+                <a:uFillTx/>
+                <a:latin typeface="Fraunces"/>
+                <a:ea typeface="Fraunces"/>
+                <a:cs typeface="Fraunces"/>
+                <a:sym typeface="Fraunces"/>
+              </a:rPr>
+              <a:t>elevenLabs</a:t>
             </a:r>
             <a:endParaRPr kumimoji="0" sz="6000" b="0" i="0" u="none" strike="noStrike" kern="0" cap="none" spc="0" normalizeH="0" baseline="0" noProof="0" dirty="0">
               <a:ln>
@@ -33250,7 +33155,7 @@
         </p:nvSpPr>
         <p:spPr>
           <a:xfrm>
-            <a:off x="715523" y="4342795"/>
+            <a:off x="728493" y="5558382"/>
             <a:ext cx="1319100" cy="469800"/>
           </a:xfrm>
           <a:prstGeom prst="roundRect">
@@ -33340,7 +33245,7 @@
         </p:nvSpPr>
         <p:spPr>
           <a:xfrm>
-            <a:off x="2187136" y="4342795"/>
+            <a:off x="2200106" y="5558382"/>
             <a:ext cx="1603500" cy="469800"/>
           </a:xfrm>
           <a:prstGeom prst="roundRect">
@@ -33442,7 +33347,7 @@
         </p:nvSpPr>
         <p:spPr>
           <a:xfrm>
-            <a:off x="3943122" y="4342795"/>
+            <a:off x="3956092" y="5558382"/>
             <a:ext cx="1493100" cy="469800"/>
           </a:xfrm>
           <a:prstGeom prst="roundRect">
@@ -33532,7 +33437,7 @@
         </p:nvSpPr>
         <p:spPr>
           <a:xfrm>
-            <a:off x="5588619" y="4342795"/>
+            <a:off x="5601589" y="5558382"/>
             <a:ext cx="2108100" cy="469800"/>
           </a:xfrm>
           <a:prstGeom prst="roundRect">
@@ -33605,6 +33510,90 @@
               <a:cs typeface="Calibri"/>
               <a:sym typeface="Calibri"/>
             </a:endParaRPr>
+          </a:p>
+        </p:txBody>
+      </p:sp>
+      <p:sp>
+        <p:nvSpPr>
+          <p:cNvPr id="5" name="TextBox 4">
+            <a:extLst>
+              <a:ext uri="{FF2B5EF4-FFF2-40B4-BE49-F238E27FC236}">
+                <a16:creationId xmlns:a16="http://schemas.microsoft.com/office/drawing/2014/main" id="{3433939A-87D9-5689-2186-41414946ABBC}"/>
+              </a:ext>
+            </a:extLst>
+          </p:cNvPr>
+          <p:cNvSpPr txBox="1"/>
+          <p:nvPr/>
+        </p:nvSpPr>
+        <p:spPr>
+          <a:xfrm>
+            <a:off x="812800" y="4936919"/>
+            <a:ext cx="6096000" cy="330219"/>
+          </a:xfrm>
+          <a:prstGeom prst="rect">
+            <a:avLst/>
+          </a:prstGeom>
+          <a:noFill/>
+          <a:ln>
+            <a:noFill/>
+          </a:ln>
+        </p:spPr>
+        <p:txBody>
+          <a:bodyPr spcFirstLastPara="1" wrap="square" lIns="0" tIns="0" rIns="0" bIns="0" anchor="t" anchorCtr="0">
+            <a:noAutofit/>
+          </a:bodyPr>
+          <a:lstStyle>
+            <a:defPPr marR="0" lvl="0" algn="l" rtl="0">
+              <a:lnSpc>
+                <a:spcPct val="100000"/>
+              </a:lnSpc>
+              <a:spcBef>
+                <a:spcPts val="0"/>
+              </a:spcBef>
+              <a:spcAft>
+                <a:spcPts val="0"/>
+              </a:spcAft>
+            </a:defPPr>
+            <a:lvl1pPr marL="0" indent="0" defTabSz="914400" eaLnBrk="1" fontAlgn="auto" latinLnBrk="0" hangingPunct="1">
+              <a:lnSpc>
+                <a:spcPct val="140000"/>
+              </a:lnSpc>
+              <a:buClr>
+                <a:srgbClr val="1E3A2F"/>
+              </a:buClr>
+              <a:buSzPts val="1200"/>
+              <a:buFont typeface="DM Sans"/>
+              <a:buNone/>
+              <a:tabLst/>
+              <a:defRPr kumimoji="0" sz="1200" b="1" kern="0" normalizeH="0" baseline="0">
+                <a:ln>
+                  <a:noFill/>
+                </a:ln>
+                <a:solidFill>
+                  <a:srgbClr val="1E3A2F"/>
+                </a:solidFill>
+                <a:effectLst/>
+                <a:uLnTx/>
+                <a:uFillTx/>
+                <a:latin typeface="DM Sans"/>
+                <a:ea typeface="DM Sans"/>
+                <a:cs typeface="DM Sans"/>
+              </a:defRPr>
+            </a:lvl1pPr>
+          </a:lstStyle>
+          <a:p>
+            <a:r>
+              <a:rPr lang="en-US" dirty="0"/>
+              <a:t>https://</a:t>
+            </a:r>
+            <a:r>
+              <a:rPr lang="en-US" dirty="0" err="1"/>
+              <a:t>elevenlabs.io</a:t>
+            </a:r>
+            <a:r>
+              <a:rPr lang="en-US" dirty="0"/>
+              <a:t>/</a:t>
+            </a:r>
           </a:p>
         </p:txBody>
       </p:sp>

</xml_diff>